<commit_message>
finished presentation, created handout
</commit_message>
<xml_diff>
--- a/images/kontext.pptx
+++ b/images/kontext.pptx
@@ -105,6 +105,11 @@
       </a:defRPr>
     </a:lvl9pPr>
   </p:defaultTextStyle>
+  <p:extLst>
+    <p:ext uri="{EFAFB233-063F-42B5-8137-9DF3F51BA10A}">
+      <p15:sldGuideLst xmlns:p15="http://schemas.microsoft.com/office/powerpoint/2012/main"/>
+    </p:ext>
+  </p:extLst>
 </p:presentation>
 </file>
 
@@ -255,7 +260,7 @@
           <a:p>
             <a:fld id="{7D7F1858-A516-4078-8282-F592DCC75031}" type="datetimeFigureOut">
               <a:rPr lang="de-DE" smtClean="0"/>
-              <a:t>06.10.2026</a:t>
+              <a:t>07.10.2026</a:t>
             </a:fld>
             <a:endParaRPr lang="de-DE"/>
           </a:p>
@@ -453,7 +458,7 @@
           <a:p>
             <a:fld id="{7D7F1858-A516-4078-8282-F592DCC75031}" type="datetimeFigureOut">
               <a:rPr lang="de-DE" smtClean="0"/>
-              <a:t>06.10.2026</a:t>
+              <a:t>07.10.2026</a:t>
             </a:fld>
             <a:endParaRPr lang="de-DE"/>
           </a:p>
@@ -661,7 +666,7 @@
           <a:p>
             <a:fld id="{7D7F1858-A516-4078-8282-F592DCC75031}" type="datetimeFigureOut">
               <a:rPr lang="de-DE" smtClean="0"/>
-              <a:t>06.10.2026</a:t>
+              <a:t>07.10.2026</a:t>
             </a:fld>
             <a:endParaRPr lang="de-DE"/>
           </a:p>
@@ -859,7 +864,7 @@
           <a:p>
             <a:fld id="{7D7F1858-A516-4078-8282-F592DCC75031}" type="datetimeFigureOut">
               <a:rPr lang="de-DE" smtClean="0"/>
-              <a:t>06.10.2026</a:t>
+              <a:t>07.10.2026</a:t>
             </a:fld>
             <a:endParaRPr lang="de-DE"/>
           </a:p>
@@ -1134,7 +1139,7 @@
           <a:p>
             <a:fld id="{7D7F1858-A516-4078-8282-F592DCC75031}" type="datetimeFigureOut">
               <a:rPr lang="de-DE" smtClean="0"/>
-              <a:t>06.10.2026</a:t>
+              <a:t>07.10.2026</a:t>
             </a:fld>
             <a:endParaRPr lang="de-DE"/>
           </a:p>
@@ -1399,7 +1404,7 @@
           <a:p>
             <a:fld id="{7D7F1858-A516-4078-8282-F592DCC75031}" type="datetimeFigureOut">
               <a:rPr lang="de-DE" smtClean="0"/>
-              <a:t>06.10.2026</a:t>
+              <a:t>07.10.2026</a:t>
             </a:fld>
             <a:endParaRPr lang="de-DE"/>
           </a:p>
@@ -1811,7 +1816,7 @@
           <a:p>
             <a:fld id="{7D7F1858-A516-4078-8282-F592DCC75031}" type="datetimeFigureOut">
               <a:rPr lang="de-DE" smtClean="0"/>
-              <a:t>06.10.2026</a:t>
+              <a:t>07.10.2026</a:t>
             </a:fld>
             <a:endParaRPr lang="de-DE"/>
           </a:p>
@@ -1952,7 +1957,7 @@
           <a:p>
             <a:fld id="{7D7F1858-A516-4078-8282-F592DCC75031}" type="datetimeFigureOut">
               <a:rPr lang="de-DE" smtClean="0"/>
-              <a:t>06.10.2026</a:t>
+              <a:t>07.10.2026</a:t>
             </a:fld>
             <a:endParaRPr lang="de-DE"/>
           </a:p>
@@ -2065,7 +2070,7 @@
           <a:p>
             <a:fld id="{7D7F1858-A516-4078-8282-F592DCC75031}" type="datetimeFigureOut">
               <a:rPr lang="de-DE" smtClean="0"/>
-              <a:t>06.10.2026</a:t>
+              <a:t>07.10.2026</a:t>
             </a:fld>
             <a:endParaRPr lang="de-DE"/>
           </a:p>
@@ -2376,7 +2381,7 @@
           <a:p>
             <a:fld id="{7D7F1858-A516-4078-8282-F592DCC75031}" type="datetimeFigureOut">
               <a:rPr lang="de-DE" smtClean="0"/>
-              <a:t>06.10.2026</a:t>
+              <a:t>07.10.2026</a:t>
             </a:fld>
             <a:endParaRPr lang="de-DE"/>
           </a:p>
@@ -2664,7 +2669,7 @@
           <a:p>
             <a:fld id="{7D7F1858-A516-4078-8282-F592DCC75031}" type="datetimeFigureOut">
               <a:rPr lang="de-DE" smtClean="0"/>
-              <a:t>06.10.2026</a:t>
+              <a:t>07.10.2026</a:t>
             </a:fld>
             <a:endParaRPr lang="de-DE"/>
           </a:p>
@@ -2905,7 +2910,7 @@
           <a:p>
             <a:fld id="{7D7F1858-A516-4078-8282-F592DCC75031}" type="datetimeFigureOut">
               <a:rPr lang="de-DE" smtClean="0"/>
-              <a:t>06.10.2026</a:t>
+              <a:t>07.10.2026</a:t>
             </a:fld>
             <a:endParaRPr lang="de-DE"/>
           </a:p>
@@ -4278,6 +4283,9 @@
             <a:avLst/>
           </a:prstGeom>
           <a:ln w="38100">
+            <a:solidFill>
+              <a:srgbClr val="C00000"/>
+            </a:solidFill>
             <a:headEnd type="triangle"/>
             <a:tailEnd type="triangle"/>
           </a:ln>
@@ -4320,6 +4328,9 @@
             <a:avLst/>
           </a:prstGeom>
           <a:ln w="38100">
+            <a:solidFill>
+              <a:srgbClr val="C00000"/>
+            </a:solidFill>
             <a:headEnd type="triangle"/>
             <a:tailEnd type="triangle"/>
           </a:ln>
@@ -4412,7 +4423,7 @@
         </p:blipFill>
         <p:spPr>
           <a:xfrm>
-            <a:off x="5720740" y="3984508"/>
+            <a:off x="5704711" y="2822824"/>
             <a:ext cx="914400" cy="914400"/>
           </a:xfrm>
           <a:prstGeom prst="rect">

</xml_diff>